<commit_message>
Fix workout heading overlap; add dedup/quality checker and grade driver
- assessment.py: bind a roomier header chrome to each workout Builder so the
  badge ("QUIZ QUESTION") no longer collides with the question title
  ("Q16 - Shadow") in PowerPoint; concept decks are untouched.
- Add concept_corpus()/dedup_report(): flag any new question stem that repeats
  another new question or a concept-deck quiz question.
- Add build_grade(): generic per-grade driver (validation + dedup report +
  option balancing + build + QA), so each bank_gNN.py is just data.
- Rebuild Grade 6 with the spaced heading.

Co-Authored-By: Claude Opus 4.8 <noreply@anthropic.com>
Claude-Session: https://claude.ai/code/session_01EtUrvF56uWBVodm4jXyhC8
</commit_message>
<xml_diff>
--- a/workouts/Grade06/G06_Light_Workout.pptx
+++ b/workouts/Grade06/G06_Light_Workout.pptx
@@ -4543,8 +4543,8 @@
         </p:nvSpPr>
         <p:spPr>
           <a:xfrm>
-            <a:off x="548640" y="502920"/>
-            <a:ext cx="256032" cy="256032"/>
+            <a:off x="548640" y="475488"/>
+            <a:ext cx="237744" cy="237744"/>
           </a:xfrm>
           <a:prstGeom prst="rect">
             <a:avLst/>
@@ -4587,8 +4587,8 @@
         </p:nvSpPr>
         <p:spPr>
           <a:xfrm>
-            <a:off x="914400" y="457200"/>
-            <a:ext cx="9509760" cy="320040"/>
+            <a:off x="914400" y="402336"/>
+            <a:ext cx="9509760" cy="310896"/>
           </a:xfrm>
           <a:prstGeom prst="rect">
             <a:avLst/>
@@ -4603,7 +4603,7 @@
           <a:p>
             <a:pPr algn="l"/>
             <a:r>
-              <a:rPr sz="1300" b="1" i="0">
+              <a:rPr sz="1250" b="1" i="0">
                 <a:solidFill>
                   <a:srgbClr val="F4801A"/>
                 </a:solidFill>
@@ -4622,8 +4622,8 @@
         </p:nvSpPr>
         <p:spPr>
           <a:xfrm>
-            <a:off x="548640" y="777240"/>
-            <a:ext cx="9966960" cy="822960"/>
+            <a:off x="548640" y="932688"/>
+            <a:ext cx="9966960" cy="777240"/>
           </a:xfrm>
           <a:prstGeom prst="rect">
             <a:avLst/>
@@ -4638,7 +4638,7 @@
           <a:p>
             <a:pPr algn="l"/>
             <a:r>
-              <a:rPr sz="3000" b="1" i="0">
+              <a:rPr sz="2700" b="1" i="0">
                 <a:solidFill>
                   <a:srgbClr val="1D2433"/>
                 </a:solidFill>
@@ -5625,8 +5625,8 @@
         </p:nvSpPr>
         <p:spPr>
           <a:xfrm>
-            <a:off x="548640" y="502920"/>
-            <a:ext cx="256032" cy="256032"/>
+            <a:off x="548640" y="475488"/>
+            <a:ext cx="237744" cy="237744"/>
           </a:xfrm>
           <a:prstGeom prst="rect">
             <a:avLst/>
@@ -5669,8 +5669,8 @@
         </p:nvSpPr>
         <p:spPr>
           <a:xfrm>
-            <a:off x="914400" y="457200"/>
-            <a:ext cx="9509760" cy="320040"/>
+            <a:off x="914400" y="402336"/>
+            <a:ext cx="9509760" cy="310896"/>
           </a:xfrm>
           <a:prstGeom prst="rect">
             <a:avLst/>
@@ -5685,7 +5685,7 @@
           <a:p>
             <a:pPr algn="l"/>
             <a:r>
-              <a:rPr sz="1300" b="1" i="0">
+              <a:rPr sz="1250" b="1" i="0">
                 <a:solidFill>
                   <a:srgbClr val="F4801A"/>
                 </a:solidFill>
@@ -5704,8 +5704,8 @@
         </p:nvSpPr>
         <p:spPr>
           <a:xfrm>
-            <a:off x="548640" y="777240"/>
-            <a:ext cx="9966960" cy="822960"/>
+            <a:off x="548640" y="932688"/>
+            <a:ext cx="9966960" cy="777240"/>
           </a:xfrm>
           <a:prstGeom prst="rect">
             <a:avLst/>
@@ -5720,7 +5720,7 @@
           <a:p>
             <a:pPr algn="l"/>
             <a:r>
-              <a:rPr sz="3000" b="1" i="0">
+              <a:rPr sz="2700" b="1" i="0">
                 <a:solidFill>
                   <a:srgbClr val="1D2433"/>
                 </a:solidFill>
@@ -6536,8 +6536,8 @@
         </p:nvSpPr>
         <p:spPr>
           <a:xfrm>
-            <a:off x="548640" y="502920"/>
-            <a:ext cx="256032" cy="256032"/>
+            <a:off x="548640" y="475488"/>
+            <a:ext cx="237744" cy="237744"/>
           </a:xfrm>
           <a:prstGeom prst="rect">
             <a:avLst/>
@@ -6580,8 +6580,8 @@
         </p:nvSpPr>
         <p:spPr>
           <a:xfrm>
-            <a:off x="914400" y="457200"/>
-            <a:ext cx="9509760" cy="320040"/>
+            <a:off x="914400" y="402336"/>
+            <a:ext cx="9509760" cy="310896"/>
           </a:xfrm>
           <a:prstGeom prst="rect">
             <a:avLst/>
@@ -6596,7 +6596,7 @@
           <a:p>
             <a:pPr algn="l"/>
             <a:r>
-              <a:rPr sz="1300" b="1" i="0">
+              <a:rPr sz="1250" b="1" i="0">
                 <a:solidFill>
                   <a:srgbClr val="F4801A"/>
                 </a:solidFill>
@@ -6615,8 +6615,8 @@
         </p:nvSpPr>
         <p:spPr>
           <a:xfrm>
-            <a:off x="548640" y="777240"/>
-            <a:ext cx="9966960" cy="822960"/>
+            <a:off x="548640" y="932688"/>
+            <a:ext cx="9966960" cy="777240"/>
           </a:xfrm>
           <a:prstGeom prst="rect">
             <a:avLst/>
@@ -6631,7 +6631,7 @@
           <a:p>
             <a:pPr algn="l"/>
             <a:r>
-              <a:rPr sz="3000" b="1" i="0">
+              <a:rPr sz="2700" b="1" i="0">
                 <a:solidFill>
                   <a:srgbClr val="1D2433"/>
                 </a:solidFill>
@@ -7618,8 +7618,8 @@
         </p:nvSpPr>
         <p:spPr>
           <a:xfrm>
-            <a:off x="548640" y="502920"/>
-            <a:ext cx="256032" cy="256032"/>
+            <a:off x="548640" y="475488"/>
+            <a:ext cx="237744" cy="237744"/>
           </a:xfrm>
           <a:prstGeom prst="rect">
             <a:avLst/>
@@ -7662,8 +7662,8 @@
         </p:nvSpPr>
         <p:spPr>
           <a:xfrm>
-            <a:off x="914400" y="457200"/>
-            <a:ext cx="9509760" cy="320040"/>
+            <a:off x="914400" y="402336"/>
+            <a:ext cx="9509760" cy="310896"/>
           </a:xfrm>
           <a:prstGeom prst="rect">
             <a:avLst/>
@@ -7678,7 +7678,7 @@
           <a:p>
             <a:pPr algn="l"/>
             <a:r>
-              <a:rPr sz="1300" b="1" i="0">
+              <a:rPr sz="1250" b="1" i="0">
                 <a:solidFill>
                   <a:srgbClr val="F4801A"/>
                 </a:solidFill>
@@ -7697,8 +7697,8 @@
         </p:nvSpPr>
         <p:spPr>
           <a:xfrm>
-            <a:off x="548640" y="777240"/>
-            <a:ext cx="9966960" cy="822960"/>
+            <a:off x="548640" y="932688"/>
+            <a:ext cx="9966960" cy="777240"/>
           </a:xfrm>
           <a:prstGeom prst="rect">
             <a:avLst/>
@@ -7713,7 +7713,7 @@
           <a:p>
             <a:pPr algn="l"/>
             <a:r>
-              <a:rPr sz="3000" b="1" i="0">
+              <a:rPr sz="2700" b="1" i="0">
                 <a:solidFill>
                   <a:srgbClr val="1D2433"/>
                 </a:solidFill>
@@ -8529,8 +8529,8 @@
         </p:nvSpPr>
         <p:spPr>
           <a:xfrm>
-            <a:off x="548640" y="502920"/>
-            <a:ext cx="256032" cy="256032"/>
+            <a:off x="548640" y="475488"/>
+            <a:ext cx="237744" cy="237744"/>
           </a:xfrm>
           <a:prstGeom prst="rect">
             <a:avLst/>
@@ -8573,8 +8573,8 @@
         </p:nvSpPr>
         <p:spPr>
           <a:xfrm>
-            <a:off x="914400" y="457200"/>
-            <a:ext cx="9509760" cy="320040"/>
+            <a:off x="914400" y="402336"/>
+            <a:ext cx="9509760" cy="310896"/>
           </a:xfrm>
           <a:prstGeom prst="rect">
             <a:avLst/>
@@ -8589,7 +8589,7 @@
           <a:p>
             <a:pPr algn="l"/>
             <a:r>
-              <a:rPr sz="1300" b="1" i="0">
+              <a:rPr sz="1250" b="1" i="0">
                 <a:solidFill>
                   <a:srgbClr val="F4801A"/>
                 </a:solidFill>
@@ -8608,8 +8608,8 @@
         </p:nvSpPr>
         <p:spPr>
           <a:xfrm>
-            <a:off x="548640" y="777240"/>
-            <a:ext cx="9966960" cy="822960"/>
+            <a:off x="548640" y="932688"/>
+            <a:ext cx="9966960" cy="777240"/>
           </a:xfrm>
           <a:prstGeom prst="rect">
             <a:avLst/>
@@ -8624,7 +8624,7 @@
           <a:p>
             <a:pPr algn="l"/>
             <a:r>
-              <a:rPr sz="3000" b="1" i="0">
+              <a:rPr sz="2700" b="1" i="0">
                 <a:solidFill>
                   <a:srgbClr val="1D2433"/>
                 </a:solidFill>
@@ -9611,8 +9611,8 @@
         </p:nvSpPr>
         <p:spPr>
           <a:xfrm>
-            <a:off x="548640" y="502920"/>
-            <a:ext cx="256032" cy="256032"/>
+            <a:off x="548640" y="475488"/>
+            <a:ext cx="237744" cy="237744"/>
           </a:xfrm>
           <a:prstGeom prst="rect">
             <a:avLst/>
@@ -9655,8 +9655,8 @@
         </p:nvSpPr>
         <p:spPr>
           <a:xfrm>
-            <a:off x="914400" y="457200"/>
-            <a:ext cx="9509760" cy="320040"/>
+            <a:off x="914400" y="402336"/>
+            <a:ext cx="9509760" cy="310896"/>
           </a:xfrm>
           <a:prstGeom prst="rect">
             <a:avLst/>
@@ -9671,7 +9671,7 @@
           <a:p>
             <a:pPr algn="l"/>
             <a:r>
-              <a:rPr sz="1300" b="1" i="0">
+              <a:rPr sz="1250" b="1" i="0">
                 <a:solidFill>
                   <a:srgbClr val="F4801A"/>
                 </a:solidFill>
@@ -9690,8 +9690,8 @@
         </p:nvSpPr>
         <p:spPr>
           <a:xfrm>
-            <a:off x="548640" y="777240"/>
-            <a:ext cx="9966960" cy="822960"/>
+            <a:off x="548640" y="932688"/>
+            <a:ext cx="9966960" cy="777240"/>
           </a:xfrm>
           <a:prstGeom prst="rect">
             <a:avLst/>
@@ -9706,7 +9706,7 @@
           <a:p>
             <a:pPr algn="l"/>
             <a:r>
-              <a:rPr sz="3000" b="1" i="0">
+              <a:rPr sz="2700" b="1" i="0">
                 <a:solidFill>
                   <a:srgbClr val="1D2433"/>
                 </a:solidFill>
@@ -10522,8 +10522,8 @@
         </p:nvSpPr>
         <p:spPr>
           <a:xfrm>
-            <a:off x="548640" y="502920"/>
-            <a:ext cx="256032" cy="256032"/>
+            <a:off x="548640" y="475488"/>
+            <a:ext cx="237744" cy="237744"/>
           </a:xfrm>
           <a:prstGeom prst="rect">
             <a:avLst/>
@@ -10566,8 +10566,8 @@
         </p:nvSpPr>
         <p:spPr>
           <a:xfrm>
-            <a:off x="914400" y="457200"/>
-            <a:ext cx="9509760" cy="320040"/>
+            <a:off x="914400" y="402336"/>
+            <a:ext cx="9509760" cy="310896"/>
           </a:xfrm>
           <a:prstGeom prst="rect">
             <a:avLst/>
@@ -10582,7 +10582,7 @@
           <a:p>
             <a:pPr algn="l"/>
             <a:r>
-              <a:rPr sz="1300" b="1" i="0">
+              <a:rPr sz="1250" b="1" i="0">
                 <a:solidFill>
                   <a:srgbClr val="F4801A"/>
                 </a:solidFill>
@@ -10601,8 +10601,8 @@
         </p:nvSpPr>
         <p:spPr>
           <a:xfrm>
-            <a:off x="548640" y="777240"/>
-            <a:ext cx="9966960" cy="822960"/>
+            <a:off x="548640" y="932688"/>
+            <a:ext cx="9966960" cy="777240"/>
           </a:xfrm>
           <a:prstGeom prst="rect">
             <a:avLst/>
@@ -10617,7 +10617,7 @@
           <a:p>
             <a:pPr algn="l"/>
             <a:r>
-              <a:rPr sz="3000" b="1" i="0">
+              <a:rPr sz="2700" b="1" i="0">
                 <a:solidFill>
                   <a:srgbClr val="1D2433"/>
                 </a:solidFill>
@@ -11604,8 +11604,8 @@
         </p:nvSpPr>
         <p:spPr>
           <a:xfrm>
-            <a:off x="548640" y="502920"/>
-            <a:ext cx="256032" cy="256032"/>
+            <a:off x="548640" y="475488"/>
+            <a:ext cx="237744" cy="237744"/>
           </a:xfrm>
           <a:prstGeom prst="rect">
             <a:avLst/>
@@ -11648,8 +11648,8 @@
         </p:nvSpPr>
         <p:spPr>
           <a:xfrm>
-            <a:off x="914400" y="457200"/>
-            <a:ext cx="9509760" cy="320040"/>
+            <a:off x="914400" y="402336"/>
+            <a:ext cx="9509760" cy="310896"/>
           </a:xfrm>
           <a:prstGeom prst="rect">
             <a:avLst/>
@@ -11664,7 +11664,7 @@
           <a:p>
             <a:pPr algn="l"/>
             <a:r>
-              <a:rPr sz="1300" b="1" i="0">
+              <a:rPr sz="1250" b="1" i="0">
                 <a:solidFill>
                   <a:srgbClr val="F4801A"/>
                 </a:solidFill>
@@ -11683,8 +11683,8 @@
         </p:nvSpPr>
         <p:spPr>
           <a:xfrm>
-            <a:off x="548640" y="777240"/>
-            <a:ext cx="9966960" cy="822960"/>
+            <a:off x="548640" y="932688"/>
+            <a:ext cx="9966960" cy="777240"/>
           </a:xfrm>
           <a:prstGeom prst="rect">
             <a:avLst/>
@@ -11699,7 +11699,7 @@
           <a:p>
             <a:pPr algn="l"/>
             <a:r>
-              <a:rPr sz="3000" b="1" i="0">
+              <a:rPr sz="2700" b="1" i="0">
                 <a:solidFill>
                   <a:srgbClr val="1D2433"/>
                 </a:solidFill>
@@ -12515,8 +12515,8 @@
         </p:nvSpPr>
         <p:spPr>
           <a:xfrm>
-            <a:off x="548640" y="502920"/>
-            <a:ext cx="256032" cy="256032"/>
+            <a:off x="548640" y="475488"/>
+            <a:ext cx="237744" cy="237744"/>
           </a:xfrm>
           <a:prstGeom prst="rect">
             <a:avLst/>
@@ -12559,8 +12559,8 @@
         </p:nvSpPr>
         <p:spPr>
           <a:xfrm>
-            <a:off x="914400" y="457200"/>
-            <a:ext cx="9509760" cy="320040"/>
+            <a:off x="914400" y="402336"/>
+            <a:ext cx="9509760" cy="310896"/>
           </a:xfrm>
           <a:prstGeom prst="rect">
             <a:avLst/>
@@ -12575,7 +12575,7 @@
           <a:p>
             <a:pPr algn="l"/>
             <a:r>
-              <a:rPr sz="1300" b="1" i="0">
+              <a:rPr sz="1250" b="1" i="0">
                 <a:solidFill>
                   <a:srgbClr val="F4801A"/>
                 </a:solidFill>
@@ -12594,8 +12594,8 @@
         </p:nvSpPr>
         <p:spPr>
           <a:xfrm>
-            <a:off x="548640" y="777240"/>
-            <a:ext cx="9966960" cy="822960"/>
+            <a:off x="548640" y="932688"/>
+            <a:ext cx="9966960" cy="777240"/>
           </a:xfrm>
           <a:prstGeom prst="rect">
             <a:avLst/>
@@ -12610,7 +12610,7 @@
           <a:p>
             <a:pPr algn="l"/>
             <a:r>
-              <a:rPr sz="3000" b="1" i="0">
+              <a:rPr sz="2700" b="1" i="0">
                 <a:solidFill>
                   <a:srgbClr val="1D2433"/>
                 </a:solidFill>
@@ -13597,8 +13597,8 @@
         </p:nvSpPr>
         <p:spPr>
           <a:xfrm>
-            <a:off x="548640" y="502920"/>
-            <a:ext cx="256032" cy="256032"/>
+            <a:off x="548640" y="475488"/>
+            <a:ext cx="237744" cy="237744"/>
           </a:xfrm>
           <a:prstGeom prst="rect">
             <a:avLst/>
@@ -13641,8 +13641,8 @@
         </p:nvSpPr>
         <p:spPr>
           <a:xfrm>
-            <a:off x="914400" y="457200"/>
-            <a:ext cx="9509760" cy="320040"/>
+            <a:off x="914400" y="402336"/>
+            <a:ext cx="9509760" cy="310896"/>
           </a:xfrm>
           <a:prstGeom prst="rect">
             <a:avLst/>
@@ -13657,7 +13657,7 @@
           <a:p>
             <a:pPr algn="l"/>
             <a:r>
-              <a:rPr sz="1300" b="1" i="0">
+              <a:rPr sz="1250" b="1" i="0">
                 <a:solidFill>
                   <a:srgbClr val="F4801A"/>
                 </a:solidFill>
@@ -13676,8 +13676,8 @@
         </p:nvSpPr>
         <p:spPr>
           <a:xfrm>
-            <a:off x="548640" y="777240"/>
-            <a:ext cx="9966960" cy="822960"/>
+            <a:off x="548640" y="932688"/>
+            <a:ext cx="9966960" cy="777240"/>
           </a:xfrm>
           <a:prstGeom prst="rect">
             <a:avLst/>
@@ -13692,7 +13692,7 @@
           <a:p>
             <a:pPr algn="l"/>
             <a:r>
-              <a:rPr sz="3000" b="1" i="0">
+              <a:rPr sz="2700" b="1" i="0">
                 <a:solidFill>
                   <a:srgbClr val="1D2433"/>
                 </a:solidFill>
@@ -14508,8 +14508,8 @@
         </p:nvSpPr>
         <p:spPr>
           <a:xfrm>
-            <a:off x="548640" y="502920"/>
-            <a:ext cx="256032" cy="256032"/>
+            <a:off x="548640" y="475488"/>
+            <a:ext cx="237744" cy="237744"/>
           </a:xfrm>
           <a:prstGeom prst="rect">
             <a:avLst/>
@@ -14552,8 +14552,8 @@
         </p:nvSpPr>
         <p:spPr>
           <a:xfrm>
-            <a:off x="914400" y="457200"/>
-            <a:ext cx="9509760" cy="320040"/>
+            <a:off x="914400" y="402336"/>
+            <a:ext cx="9509760" cy="310896"/>
           </a:xfrm>
           <a:prstGeom prst="rect">
             <a:avLst/>
@@ -14568,7 +14568,7 @@
           <a:p>
             <a:pPr algn="l"/>
             <a:r>
-              <a:rPr sz="1300" b="1" i="0">
+              <a:rPr sz="1250" b="1" i="0">
                 <a:solidFill>
                   <a:srgbClr val="F4801A"/>
                 </a:solidFill>
@@ -14587,8 +14587,8 @@
         </p:nvSpPr>
         <p:spPr>
           <a:xfrm>
-            <a:off x="548640" y="777240"/>
-            <a:ext cx="9966960" cy="822960"/>
+            <a:off x="548640" y="932688"/>
+            <a:ext cx="9966960" cy="777240"/>
           </a:xfrm>
           <a:prstGeom prst="rect">
             <a:avLst/>
@@ -14603,7 +14603,7 @@
           <a:p>
             <a:pPr algn="l"/>
             <a:r>
-              <a:rPr sz="3000" b="1" i="0">
+              <a:rPr sz="2700" b="1" i="0">
                 <a:solidFill>
                   <a:srgbClr val="1D2433"/>
                 </a:solidFill>
@@ -14876,8 +14876,8 @@
         </p:nvSpPr>
         <p:spPr>
           <a:xfrm>
-            <a:off x="548640" y="502920"/>
-            <a:ext cx="256032" cy="256032"/>
+            <a:off x="548640" y="475488"/>
+            <a:ext cx="237744" cy="237744"/>
           </a:xfrm>
           <a:prstGeom prst="rect">
             <a:avLst/>
@@ -14920,8 +14920,8 @@
         </p:nvSpPr>
         <p:spPr>
           <a:xfrm>
-            <a:off x="914400" y="457200"/>
-            <a:ext cx="9509760" cy="320040"/>
+            <a:off x="914400" y="402336"/>
+            <a:ext cx="9509760" cy="310896"/>
           </a:xfrm>
           <a:prstGeom prst="rect">
             <a:avLst/>
@@ -14936,7 +14936,7 @@
           <a:p>
             <a:pPr algn="l"/>
             <a:r>
-              <a:rPr sz="1300" b="1" i="0">
+              <a:rPr sz="1250" b="1" i="0">
                 <a:solidFill>
                   <a:srgbClr val="F4801A"/>
                 </a:solidFill>
@@ -14955,8 +14955,8 @@
         </p:nvSpPr>
         <p:spPr>
           <a:xfrm>
-            <a:off x="548640" y="777240"/>
-            <a:ext cx="9966960" cy="822960"/>
+            <a:off x="548640" y="932688"/>
+            <a:ext cx="9966960" cy="777240"/>
           </a:xfrm>
           <a:prstGeom prst="rect">
             <a:avLst/>
@@ -14971,7 +14971,7 @@
           <a:p>
             <a:pPr algn="l"/>
             <a:r>
-              <a:rPr sz="3000" b="1" i="0">
+              <a:rPr sz="2700" b="1" i="0">
                 <a:solidFill>
                   <a:srgbClr val="1D2433"/>
                 </a:solidFill>
@@ -15958,8 +15958,8 @@
         </p:nvSpPr>
         <p:spPr>
           <a:xfrm>
-            <a:off x="548640" y="502920"/>
-            <a:ext cx="256032" cy="256032"/>
+            <a:off x="548640" y="475488"/>
+            <a:ext cx="237744" cy="237744"/>
           </a:xfrm>
           <a:prstGeom prst="rect">
             <a:avLst/>
@@ -16002,8 +16002,8 @@
         </p:nvSpPr>
         <p:spPr>
           <a:xfrm>
-            <a:off x="914400" y="457200"/>
-            <a:ext cx="9509760" cy="320040"/>
+            <a:off x="914400" y="402336"/>
+            <a:ext cx="9509760" cy="310896"/>
           </a:xfrm>
           <a:prstGeom prst="rect">
             <a:avLst/>
@@ -16018,7 +16018,7 @@
           <a:p>
             <a:pPr algn="l"/>
             <a:r>
-              <a:rPr sz="1300" b="1" i="0">
+              <a:rPr sz="1250" b="1" i="0">
                 <a:solidFill>
                   <a:srgbClr val="F4801A"/>
                 </a:solidFill>
@@ -16037,8 +16037,8 @@
         </p:nvSpPr>
         <p:spPr>
           <a:xfrm>
-            <a:off x="548640" y="777240"/>
-            <a:ext cx="9966960" cy="822960"/>
+            <a:off x="548640" y="932688"/>
+            <a:ext cx="9966960" cy="777240"/>
           </a:xfrm>
           <a:prstGeom prst="rect">
             <a:avLst/>
@@ -16053,7 +16053,7 @@
           <a:p>
             <a:pPr algn="l"/>
             <a:r>
-              <a:rPr sz="3000" b="1" i="0">
+              <a:rPr sz="2700" b="1" i="0">
                 <a:solidFill>
                   <a:srgbClr val="1D2433"/>
                 </a:solidFill>
@@ -16869,8 +16869,8 @@
         </p:nvSpPr>
         <p:spPr>
           <a:xfrm>
-            <a:off x="548640" y="502920"/>
-            <a:ext cx="256032" cy="256032"/>
+            <a:off x="548640" y="475488"/>
+            <a:ext cx="237744" cy="237744"/>
           </a:xfrm>
           <a:prstGeom prst="rect">
             <a:avLst/>
@@ -16913,8 +16913,8 @@
         </p:nvSpPr>
         <p:spPr>
           <a:xfrm>
-            <a:off x="914400" y="457200"/>
-            <a:ext cx="9509760" cy="320040"/>
+            <a:off x="914400" y="402336"/>
+            <a:ext cx="9509760" cy="310896"/>
           </a:xfrm>
           <a:prstGeom prst="rect">
             <a:avLst/>
@@ -16929,7 +16929,7 @@
           <a:p>
             <a:pPr algn="l"/>
             <a:r>
-              <a:rPr sz="1300" b="1" i="0">
+              <a:rPr sz="1250" b="1" i="0">
                 <a:solidFill>
                   <a:srgbClr val="F4801A"/>
                 </a:solidFill>
@@ -16948,8 +16948,8 @@
         </p:nvSpPr>
         <p:spPr>
           <a:xfrm>
-            <a:off x="548640" y="777240"/>
-            <a:ext cx="9966960" cy="822960"/>
+            <a:off x="548640" y="932688"/>
+            <a:ext cx="9966960" cy="777240"/>
           </a:xfrm>
           <a:prstGeom prst="rect">
             <a:avLst/>
@@ -16964,7 +16964,7 @@
           <a:p>
             <a:pPr algn="l"/>
             <a:r>
-              <a:rPr sz="3000" b="1" i="0">
+              <a:rPr sz="2700" b="1" i="0">
                 <a:solidFill>
                   <a:srgbClr val="1D2433"/>
                 </a:solidFill>
@@ -17951,8 +17951,8 @@
         </p:nvSpPr>
         <p:spPr>
           <a:xfrm>
-            <a:off x="548640" y="502920"/>
-            <a:ext cx="256032" cy="256032"/>
+            <a:off x="548640" y="475488"/>
+            <a:ext cx="237744" cy="237744"/>
           </a:xfrm>
           <a:prstGeom prst="rect">
             <a:avLst/>
@@ -17995,8 +17995,8 @@
         </p:nvSpPr>
         <p:spPr>
           <a:xfrm>
-            <a:off x="914400" y="457200"/>
-            <a:ext cx="9509760" cy="320040"/>
+            <a:off x="914400" y="402336"/>
+            <a:ext cx="9509760" cy="310896"/>
           </a:xfrm>
           <a:prstGeom prst="rect">
             <a:avLst/>
@@ -18011,7 +18011,7 @@
           <a:p>
             <a:pPr algn="l"/>
             <a:r>
-              <a:rPr sz="1300" b="1" i="0">
+              <a:rPr sz="1250" b="1" i="0">
                 <a:solidFill>
                   <a:srgbClr val="F4801A"/>
                 </a:solidFill>
@@ -18030,8 +18030,8 @@
         </p:nvSpPr>
         <p:spPr>
           <a:xfrm>
-            <a:off x="548640" y="777240"/>
-            <a:ext cx="9966960" cy="822960"/>
+            <a:off x="548640" y="932688"/>
+            <a:ext cx="9966960" cy="777240"/>
           </a:xfrm>
           <a:prstGeom prst="rect">
             <a:avLst/>
@@ -18046,7 +18046,7 @@
           <a:p>
             <a:pPr algn="l"/>
             <a:r>
-              <a:rPr sz="3000" b="1" i="0">
+              <a:rPr sz="2700" b="1" i="0">
                 <a:solidFill>
                   <a:srgbClr val="1D2433"/>
                 </a:solidFill>
@@ -18862,8 +18862,8 @@
         </p:nvSpPr>
         <p:spPr>
           <a:xfrm>
-            <a:off x="548640" y="502920"/>
-            <a:ext cx="256032" cy="256032"/>
+            <a:off x="548640" y="475488"/>
+            <a:ext cx="237744" cy="237744"/>
           </a:xfrm>
           <a:prstGeom prst="rect">
             <a:avLst/>
@@ -18906,8 +18906,8 @@
         </p:nvSpPr>
         <p:spPr>
           <a:xfrm>
-            <a:off x="914400" y="457200"/>
-            <a:ext cx="9509760" cy="320040"/>
+            <a:off x="914400" y="402336"/>
+            <a:ext cx="9509760" cy="310896"/>
           </a:xfrm>
           <a:prstGeom prst="rect">
             <a:avLst/>
@@ -18922,7 +18922,7 @@
           <a:p>
             <a:pPr algn="l"/>
             <a:r>
-              <a:rPr sz="1300" b="1" i="0">
+              <a:rPr sz="1250" b="1" i="0">
                 <a:solidFill>
                   <a:srgbClr val="F4801A"/>
                 </a:solidFill>
@@ -18941,8 +18941,8 @@
         </p:nvSpPr>
         <p:spPr>
           <a:xfrm>
-            <a:off x="548640" y="777240"/>
-            <a:ext cx="9966960" cy="822960"/>
+            <a:off x="548640" y="932688"/>
+            <a:ext cx="9966960" cy="777240"/>
           </a:xfrm>
           <a:prstGeom prst="rect">
             <a:avLst/>
@@ -18957,7 +18957,7 @@
           <a:p>
             <a:pPr algn="l"/>
             <a:r>
-              <a:rPr sz="3000" b="1" i="0">
+              <a:rPr sz="2700" b="1" i="0">
                 <a:solidFill>
                   <a:srgbClr val="1D2433"/>
                 </a:solidFill>
@@ -19944,8 +19944,8 @@
         </p:nvSpPr>
         <p:spPr>
           <a:xfrm>
-            <a:off x="548640" y="502920"/>
-            <a:ext cx="256032" cy="256032"/>
+            <a:off x="548640" y="475488"/>
+            <a:ext cx="237744" cy="237744"/>
           </a:xfrm>
           <a:prstGeom prst="rect">
             <a:avLst/>
@@ -19988,8 +19988,8 @@
         </p:nvSpPr>
         <p:spPr>
           <a:xfrm>
-            <a:off x="914400" y="457200"/>
-            <a:ext cx="9509760" cy="320040"/>
+            <a:off x="914400" y="402336"/>
+            <a:ext cx="9509760" cy="310896"/>
           </a:xfrm>
           <a:prstGeom prst="rect">
             <a:avLst/>
@@ -20004,7 +20004,7 @@
           <a:p>
             <a:pPr algn="l"/>
             <a:r>
-              <a:rPr sz="1300" b="1" i="0">
+              <a:rPr sz="1250" b="1" i="0">
                 <a:solidFill>
                   <a:srgbClr val="F4801A"/>
                 </a:solidFill>
@@ -20023,8 +20023,8 @@
         </p:nvSpPr>
         <p:spPr>
           <a:xfrm>
-            <a:off x="548640" y="777240"/>
-            <a:ext cx="9966960" cy="822960"/>
+            <a:off x="548640" y="932688"/>
+            <a:ext cx="9966960" cy="777240"/>
           </a:xfrm>
           <a:prstGeom prst="rect">
             <a:avLst/>
@@ -20039,7 +20039,7 @@
           <a:p>
             <a:pPr algn="l"/>
             <a:r>
-              <a:rPr sz="3000" b="1" i="0">
+              <a:rPr sz="2700" b="1" i="0">
                 <a:solidFill>
                   <a:srgbClr val="1D2433"/>
                 </a:solidFill>
@@ -20855,8 +20855,8 @@
         </p:nvSpPr>
         <p:spPr>
           <a:xfrm>
-            <a:off x="548640" y="502920"/>
-            <a:ext cx="256032" cy="256032"/>
+            <a:off x="548640" y="475488"/>
+            <a:ext cx="237744" cy="237744"/>
           </a:xfrm>
           <a:prstGeom prst="rect">
             <a:avLst/>
@@ -20899,8 +20899,8 @@
         </p:nvSpPr>
         <p:spPr>
           <a:xfrm>
-            <a:off x="914400" y="457200"/>
-            <a:ext cx="9509760" cy="320040"/>
+            <a:off x="914400" y="402336"/>
+            <a:ext cx="9509760" cy="310896"/>
           </a:xfrm>
           <a:prstGeom prst="rect">
             <a:avLst/>
@@ -20915,7 +20915,7 @@
           <a:p>
             <a:pPr algn="l"/>
             <a:r>
-              <a:rPr sz="1300" b="1" i="0">
+              <a:rPr sz="1250" b="1" i="0">
                 <a:solidFill>
                   <a:srgbClr val="F4801A"/>
                 </a:solidFill>
@@ -20934,8 +20934,8 @@
         </p:nvSpPr>
         <p:spPr>
           <a:xfrm>
-            <a:off x="548640" y="777240"/>
-            <a:ext cx="9966960" cy="822960"/>
+            <a:off x="548640" y="932688"/>
+            <a:ext cx="9966960" cy="777240"/>
           </a:xfrm>
           <a:prstGeom prst="rect">
             <a:avLst/>
@@ -20950,7 +20950,7 @@
           <a:p>
             <a:pPr algn="l"/>
             <a:r>
-              <a:rPr sz="3000" b="1" i="0">
+              <a:rPr sz="2700" b="1" i="0">
                 <a:solidFill>
                   <a:srgbClr val="1D2433"/>
                 </a:solidFill>
@@ -21937,8 +21937,8 @@
         </p:nvSpPr>
         <p:spPr>
           <a:xfrm>
-            <a:off x="548640" y="502920"/>
-            <a:ext cx="256032" cy="256032"/>
+            <a:off x="548640" y="475488"/>
+            <a:ext cx="237744" cy="237744"/>
           </a:xfrm>
           <a:prstGeom prst="rect">
             <a:avLst/>
@@ -21981,8 +21981,8 @@
         </p:nvSpPr>
         <p:spPr>
           <a:xfrm>
-            <a:off x="914400" y="457200"/>
-            <a:ext cx="9509760" cy="320040"/>
+            <a:off x="914400" y="402336"/>
+            <a:ext cx="9509760" cy="310896"/>
           </a:xfrm>
           <a:prstGeom prst="rect">
             <a:avLst/>
@@ -21997,7 +21997,7 @@
           <a:p>
             <a:pPr algn="l"/>
             <a:r>
-              <a:rPr sz="1300" b="1" i="0">
+              <a:rPr sz="1250" b="1" i="0">
                 <a:solidFill>
                   <a:srgbClr val="F4801A"/>
                 </a:solidFill>
@@ -22016,8 +22016,8 @@
         </p:nvSpPr>
         <p:spPr>
           <a:xfrm>
-            <a:off x="548640" y="777240"/>
-            <a:ext cx="9966960" cy="822960"/>
+            <a:off x="548640" y="932688"/>
+            <a:ext cx="9966960" cy="777240"/>
           </a:xfrm>
           <a:prstGeom prst="rect">
             <a:avLst/>
@@ -22032,7 +22032,7 @@
           <a:p>
             <a:pPr algn="l"/>
             <a:r>
-              <a:rPr sz="3000" b="1" i="0">
+              <a:rPr sz="2700" b="1" i="0">
                 <a:solidFill>
                   <a:srgbClr val="1D2433"/>
                 </a:solidFill>
@@ -22848,8 +22848,8 @@
         </p:nvSpPr>
         <p:spPr>
           <a:xfrm>
-            <a:off x="548640" y="502920"/>
-            <a:ext cx="256032" cy="256032"/>
+            <a:off x="548640" y="475488"/>
+            <a:ext cx="237744" cy="237744"/>
           </a:xfrm>
           <a:prstGeom prst="rect">
             <a:avLst/>
@@ -22892,8 +22892,8 @@
         </p:nvSpPr>
         <p:spPr>
           <a:xfrm>
-            <a:off x="914400" y="457200"/>
-            <a:ext cx="9509760" cy="320040"/>
+            <a:off x="914400" y="402336"/>
+            <a:ext cx="9509760" cy="310896"/>
           </a:xfrm>
           <a:prstGeom prst="rect">
             <a:avLst/>
@@ -22908,7 +22908,7 @@
           <a:p>
             <a:pPr algn="l"/>
             <a:r>
-              <a:rPr sz="1300" b="1" i="0">
+              <a:rPr sz="1250" b="1" i="0">
                 <a:solidFill>
                   <a:srgbClr val="F4801A"/>
                 </a:solidFill>
@@ -22927,8 +22927,8 @@
         </p:nvSpPr>
         <p:spPr>
           <a:xfrm>
-            <a:off x="548640" y="777240"/>
-            <a:ext cx="9966960" cy="822960"/>
+            <a:off x="548640" y="932688"/>
+            <a:ext cx="9966960" cy="777240"/>
           </a:xfrm>
           <a:prstGeom prst="rect">
             <a:avLst/>
@@ -22943,7 +22943,7 @@
           <a:p>
             <a:pPr algn="l"/>
             <a:r>
-              <a:rPr sz="3000" b="1" i="0">
+              <a:rPr sz="2700" b="1" i="0">
                 <a:solidFill>
                   <a:srgbClr val="1D2433"/>
                 </a:solidFill>
@@ -23930,8 +23930,8 @@
         </p:nvSpPr>
         <p:spPr>
           <a:xfrm>
-            <a:off x="548640" y="502920"/>
-            <a:ext cx="256032" cy="256032"/>
+            <a:off x="548640" y="475488"/>
+            <a:ext cx="237744" cy="237744"/>
           </a:xfrm>
           <a:prstGeom prst="rect">
             <a:avLst/>
@@ -23974,8 +23974,8 @@
         </p:nvSpPr>
         <p:spPr>
           <a:xfrm>
-            <a:off x="914400" y="457200"/>
-            <a:ext cx="9509760" cy="320040"/>
+            <a:off x="914400" y="402336"/>
+            <a:ext cx="9509760" cy="310896"/>
           </a:xfrm>
           <a:prstGeom prst="rect">
             <a:avLst/>
@@ -23990,7 +23990,7 @@
           <a:p>
             <a:pPr algn="l"/>
             <a:r>
-              <a:rPr sz="1300" b="1" i="0">
+              <a:rPr sz="1250" b="1" i="0">
                 <a:solidFill>
                   <a:srgbClr val="F4801A"/>
                 </a:solidFill>
@@ -24009,8 +24009,8 @@
         </p:nvSpPr>
         <p:spPr>
           <a:xfrm>
-            <a:off x="548640" y="777240"/>
-            <a:ext cx="9966960" cy="822960"/>
+            <a:off x="548640" y="932688"/>
+            <a:ext cx="9966960" cy="777240"/>
           </a:xfrm>
           <a:prstGeom prst="rect">
             <a:avLst/>
@@ -24025,7 +24025,7 @@
           <a:p>
             <a:pPr algn="l"/>
             <a:r>
-              <a:rPr sz="3000" b="1" i="0">
+              <a:rPr sz="2700" b="1" i="0">
                 <a:solidFill>
                   <a:srgbClr val="1D2433"/>
                 </a:solidFill>
@@ -25051,8 +25051,8 @@
         </p:nvSpPr>
         <p:spPr>
           <a:xfrm>
-            <a:off x="548640" y="502920"/>
-            <a:ext cx="256032" cy="256032"/>
+            <a:off x="548640" y="475488"/>
+            <a:ext cx="237744" cy="237744"/>
           </a:xfrm>
           <a:prstGeom prst="rect">
             <a:avLst/>
@@ -25095,8 +25095,8 @@
         </p:nvSpPr>
         <p:spPr>
           <a:xfrm>
-            <a:off x="914400" y="457200"/>
-            <a:ext cx="9509760" cy="320040"/>
+            <a:off x="914400" y="402336"/>
+            <a:ext cx="9509760" cy="310896"/>
           </a:xfrm>
           <a:prstGeom prst="rect">
             <a:avLst/>
@@ -25111,7 +25111,7 @@
           <a:p>
             <a:pPr algn="l"/>
             <a:r>
-              <a:rPr sz="1300" b="1" i="0">
+              <a:rPr sz="1250" b="1" i="0">
                 <a:solidFill>
                   <a:srgbClr val="F4801A"/>
                 </a:solidFill>
@@ -25130,8 +25130,8 @@
         </p:nvSpPr>
         <p:spPr>
           <a:xfrm>
-            <a:off x="548640" y="777240"/>
-            <a:ext cx="9966960" cy="822960"/>
+            <a:off x="548640" y="932688"/>
+            <a:ext cx="9966960" cy="777240"/>
           </a:xfrm>
           <a:prstGeom prst="rect">
             <a:avLst/>
@@ -25146,7 +25146,7 @@
           <a:p>
             <a:pPr algn="l"/>
             <a:r>
-              <a:rPr sz="3000" b="1" i="0">
+              <a:rPr sz="2700" b="1" i="0">
                 <a:solidFill>
                   <a:srgbClr val="1D2433"/>
                 </a:solidFill>
@@ -26133,8 +26133,8 @@
         </p:nvSpPr>
         <p:spPr>
           <a:xfrm>
-            <a:off x="548640" y="502920"/>
-            <a:ext cx="256032" cy="256032"/>
+            <a:off x="548640" y="475488"/>
+            <a:ext cx="237744" cy="237744"/>
           </a:xfrm>
           <a:prstGeom prst="rect">
             <a:avLst/>
@@ -26177,8 +26177,8 @@
         </p:nvSpPr>
         <p:spPr>
           <a:xfrm>
-            <a:off x="914400" y="457200"/>
-            <a:ext cx="9509760" cy="320040"/>
+            <a:off x="914400" y="402336"/>
+            <a:ext cx="9509760" cy="310896"/>
           </a:xfrm>
           <a:prstGeom prst="rect">
             <a:avLst/>
@@ -26193,7 +26193,7 @@
           <a:p>
             <a:pPr algn="l"/>
             <a:r>
-              <a:rPr sz="1300" b="1" i="0">
+              <a:rPr sz="1250" b="1" i="0">
                 <a:solidFill>
                   <a:srgbClr val="F4801A"/>
                 </a:solidFill>
@@ -26212,8 +26212,8 @@
         </p:nvSpPr>
         <p:spPr>
           <a:xfrm>
-            <a:off x="548640" y="777240"/>
-            <a:ext cx="9966960" cy="822960"/>
+            <a:off x="548640" y="932688"/>
+            <a:ext cx="9966960" cy="777240"/>
           </a:xfrm>
           <a:prstGeom prst="rect">
             <a:avLst/>
@@ -26228,7 +26228,7 @@
           <a:p>
             <a:pPr algn="l"/>
             <a:r>
-              <a:rPr sz="3000" b="1" i="0">
+              <a:rPr sz="2700" b="1" i="0">
                 <a:solidFill>
                   <a:srgbClr val="1D2433"/>
                 </a:solidFill>
@@ -27044,8 +27044,8 @@
         </p:nvSpPr>
         <p:spPr>
           <a:xfrm>
-            <a:off x="548640" y="502920"/>
-            <a:ext cx="256032" cy="256032"/>
+            <a:off x="548640" y="475488"/>
+            <a:ext cx="237744" cy="237744"/>
           </a:xfrm>
           <a:prstGeom prst="rect">
             <a:avLst/>
@@ -27088,8 +27088,8 @@
         </p:nvSpPr>
         <p:spPr>
           <a:xfrm>
-            <a:off x="914400" y="457200"/>
-            <a:ext cx="9509760" cy="320040"/>
+            <a:off x="914400" y="402336"/>
+            <a:ext cx="9509760" cy="310896"/>
           </a:xfrm>
           <a:prstGeom prst="rect">
             <a:avLst/>
@@ -27104,7 +27104,7 @@
           <a:p>
             <a:pPr algn="l"/>
             <a:r>
-              <a:rPr sz="1300" b="1" i="0">
+              <a:rPr sz="1250" b="1" i="0">
                 <a:solidFill>
                   <a:srgbClr val="F4801A"/>
                 </a:solidFill>
@@ -27123,8 +27123,8 @@
         </p:nvSpPr>
         <p:spPr>
           <a:xfrm>
-            <a:off x="548640" y="777240"/>
-            <a:ext cx="9966960" cy="822960"/>
+            <a:off x="548640" y="932688"/>
+            <a:ext cx="9966960" cy="777240"/>
           </a:xfrm>
           <a:prstGeom prst="rect">
             <a:avLst/>
@@ -27139,7 +27139,7 @@
           <a:p>
             <a:pPr algn="l"/>
             <a:r>
-              <a:rPr sz="3000" b="1" i="0">
+              <a:rPr sz="2700" b="1" i="0">
                 <a:solidFill>
                   <a:srgbClr val="1D2433"/>
                 </a:solidFill>
@@ -28126,8 +28126,8 @@
         </p:nvSpPr>
         <p:spPr>
           <a:xfrm>
-            <a:off x="548640" y="502920"/>
-            <a:ext cx="256032" cy="256032"/>
+            <a:off x="548640" y="475488"/>
+            <a:ext cx="237744" cy="237744"/>
           </a:xfrm>
           <a:prstGeom prst="rect">
             <a:avLst/>
@@ -28170,8 +28170,8 @@
         </p:nvSpPr>
         <p:spPr>
           <a:xfrm>
-            <a:off x="914400" y="457200"/>
-            <a:ext cx="9509760" cy="320040"/>
+            <a:off x="914400" y="402336"/>
+            <a:ext cx="9509760" cy="310896"/>
           </a:xfrm>
           <a:prstGeom prst="rect">
             <a:avLst/>
@@ -28186,7 +28186,7 @@
           <a:p>
             <a:pPr algn="l"/>
             <a:r>
-              <a:rPr sz="1300" b="1" i="0">
+              <a:rPr sz="1250" b="1" i="0">
                 <a:solidFill>
                   <a:srgbClr val="F4801A"/>
                 </a:solidFill>
@@ -28205,8 +28205,8 @@
         </p:nvSpPr>
         <p:spPr>
           <a:xfrm>
-            <a:off x="548640" y="777240"/>
-            <a:ext cx="9966960" cy="822960"/>
+            <a:off x="548640" y="932688"/>
+            <a:ext cx="9966960" cy="777240"/>
           </a:xfrm>
           <a:prstGeom prst="rect">
             <a:avLst/>
@@ -28221,7 +28221,7 @@
           <a:p>
             <a:pPr algn="l"/>
             <a:r>
-              <a:rPr sz="3000" b="1" i="0">
+              <a:rPr sz="2700" b="1" i="0">
                 <a:solidFill>
                   <a:srgbClr val="1D2433"/>
                 </a:solidFill>
@@ -29037,8 +29037,8 @@
         </p:nvSpPr>
         <p:spPr>
           <a:xfrm>
-            <a:off x="548640" y="502920"/>
-            <a:ext cx="256032" cy="256032"/>
+            <a:off x="548640" y="475488"/>
+            <a:ext cx="237744" cy="237744"/>
           </a:xfrm>
           <a:prstGeom prst="rect">
             <a:avLst/>
@@ -29081,8 +29081,8 @@
         </p:nvSpPr>
         <p:spPr>
           <a:xfrm>
-            <a:off x="914400" y="457200"/>
-            <a:ext cx="9509760" cy="320040"/>
+            <a:off x="914400" y="402336"/>
+            <a:ext cx="9509760" cy="310896"/>
           </a:xfrm>
           <a:prstGeom prst="rect">
             <a:avLst/>
@@ -29097,7 +29097,7 @@
           <a:p>
             <a:pPr algn="l"/>
             <a:r>
-              <a:rPr sz="1300" b="1" i="0">
+              <a:rPr sz="1250" b="1" i="0">
                 <a:solidFill>
                   <a:srgbClr val="F4801A"/>
                 </a:solidFill>
@@ -29116,8 +29116,8 @@
         </p:nvSpPr>
         <p:spPr>
           <a:xfrm>
-            <a:off x="548640" y="777240"/>
-            <a:ext cx="9966960" cy="822960"/>
+            <a:off x="548640" y="932688"/>
+            <a:ext cx="9966960" cy="777240"/>
           </a:xfrm>
           <a:prstGeom prst="rect">
             <a:avLst/>
@@ -29132,7 +29132,7 @@
           <a:p>
             <a:pPr algn="l"/>
             <a:r>
-              <a:rPr sz="3000" b="1" i="0">
+              <a:rPr sz="2700" b="1" i="0">
                 <a:solidFill>
                   <a:srgbClr val="1D2433"/>
                 </a:solidFill>
@@ -30119,8 +30119,8 @@
         </p:nvSpPr>
         <p:spPr>
           <a:xfrm>
-            <a:off x="548640" y="502920"/>
-            <a:ext cx="256032" cy="256032"/>
+            <a:off x="548640" y="475488"/>
+            <a:ext cx="237744" cy="237744"/>
           </a:xfrm>
           <a:prstGeom prst="rect">
             <a:avLst/>
@@ -30163,8 +30163,8 @@
         </p:nvSpPr>
         <p:spPr>
           <a:xfrm>
-            <a:off x="914400" y="457200"/>
-            <a:ext cx="9509760" cy="320040"/>
+            <a:off x="914400" y="402336"/>
+            <a:ext cx="9509760" cy="310896"/>
           </a:xfrm>
           <a:prstGeom prst="rect">
             <a:avLst/>
@@ -30179,7 +30179,7 @@
           <a:p>
             <a:pPr algn="l"/>
             <a:r>
-              <a:rPr sz="1300" b="1" i="0">
+              <a:rPr sz="1250" b="1" i="0">
                 <a:solidFill>
                   <a:srgbClr val="F4801A"/>
                 </a:solidFill>
@@ -30198,8 +30198,8 @@
         </p:nvSpPr>
         <p:spPr>
           <a:xfrm>
-            <a:off x="548640" y="777240"/>
-            <a:ext cx="9966960" cy="822960"/>
+            <a:off x="548640" y="932688"/>
+            <a:ext cx="9966960" cy="777240"/>
           </a:xfrm>
           <a:prstGeom prst="rect">
             <a:avLst/>
@@ -30214,7 +30214,7 @@
           <a:p>
             <a:pPr algn="l"/>
             <a:r>
-              <a:rPr sz="3000" b="1" i="0">
+              <a:rPr sz="2700" b="1" i="0">
                 <a:solidFill>
                   <a:srgbClr val="1D2433"/>
                 </a:solidFill>
@@ -31030,8 +31030,8 @@
         </p:nvSpPr>
         <p:spPr>
           <a:xfrm>
-            <a:off x="548640" y="502920"/>
-            <a:ext cx="256032" cy="256032"/>
+            <a:off x="548640" y="475488"/>
+            <a:ext cx="237744" cy="237744"/>
           </a:xfrm>
           <a:prstGeom prst="rect">
             <a:avLst/>
@@ -31074,8 +31074,8 @@
         </p:nvSpPr>
         <p:spPr>
           <a:xfrm>
-            <a:off x="914400" y="457200"/>
-            <a:ext cx="9509760" cy="320040"/>
+            <a:off x="914400" y="402336"/>
+            <a:ext cx="9509760" cy="310896"/>
           </a:xfrm>
           <a:prstGeom prst="rect">
             <a:avLst/>
@@ -31090,7 +31090,7 @@
           <a:p>
             <a:pPr algn="l"/>
             <a:r>
-              <a:rPr sz="1300" b="1" i="0">
+              <a:rPr sz="1250" b="1" i="0">
                 <a:solidFill>
                   <a:srgbClr val="F4801A"/>
                 </a:solidFill>
@@ -31109,8 +31109,8 @@
         </p:nvSpPr>
         <p:spPr>
           <a:xfrm>
-            <a:off x="548640" y="777240"/>
-            <a:ext cx="9966960" cy="822960"/>
+            <a:off x="548640" y="932688"/>
+            <a:ext cx="9966960" cy="777240"/>
           </a:xfrm>
           <a:prstGeom prst="rect">
             <a:avLst/>
@@ -31125,7 +31125,7 @@
           <a:p>
             <a:pPr algn="l"/>
             <a:r>
-              <a:rPr sz="3000" b="1" i="0">
+              <a:rPr sz="2700" b="1" i="0">
                 <a:solidFill>
                   <a:srgbClr val="1D2433"/>
                 </a:solidFill>
@@ -32112,8 +32112,8 @@
         </p:nvSpPr>
         <p:spPr>
           <a:xfrm>
-            <a:off x="548640" y="502920"/>
-            <a:ext cx="256032" cy="256032"/>
+            <a:off x="548640" y="475488"/>
+            <a:ext cx="237744" cy="237744"/>
           </a:xfrm>
           <a:prstGeom prst="rect">
             <a:avLst/>
@@ -32156,8 +32156,8 @@
         </p:nvSpPr>
         <p:spPr>
           <a:xfrm>
-            <a:off x="914400" y="457200"/>
-            <a:ext cx="9509760" cy="320040"/>
+            <a:off x="914400" y="402336"/>
+            <a:ext cx="9509760" cy="310896"/>
           </a:xfrm>
           <a:prstGeom prst="rect">
             <a:avLst/>
@@ -32172,7 +32172,7 @@
           <a:p>
             <a:pPr algn="l"/>
             <a:r>
-              <a:rPr sz="1300" b="1" i="0">
+              <a:rPr sz="1250" b="1" i="0">
                 <a:solidFill>
                   <a:srgbClr val="F4801A"/>
                 </a:solidFill>
@@ -32191,8 +32191,8 @@
         </p:nvSpPr>
         <p:spPr>
           <a:xfrm>
-            <a:off x="548640" y="777240"/>
-            <a:ext cx="9966960" cy="822960"/>
+            <a:off x="548640" y="932688"/>
+            <a:ext cx="9966960" cy="777240"/>
           </a:xfrm>
           <a:prstGeom prst="rect">
             <a:avLst/>
@@ -32207,7 +32207,7 @@
           <a:p>
             <a:pPr algn="l"/>
             <a:r>
-              <a:rPr sz="3000" b="1" i="0">
+              <a:rPr sz="2700" b="1" i="0">
                 <a:solidFill>
                   <a:srgbClr val="1D2433"/>
                 </a:solidFill>
@@ -33023,8 +33023,8 @@
         </p:nvSpPr>
         <p:spPr>
           <a:xfrm>
-            <a:off x="548640" y="502920"/>
-            <a:ext cx="256032" cy="256032"/>
+            <a:off x="548640" y="475488"/>
+            <a:ext cx="237744" cy="237744"/>
           </a:xfrm>
           <a:prstGeom prst="rect">
             <a:avLst/>
@@ -33067,8 +33067,8 @@
         </p:nvSpPr>
         <p:spPr>
           <a:xfrm>
-            <a:off x="914400" y="457200"/>
-            <a:ext cx="9509760" cy="320040"/>
+            <a:off x="914400" y="402336"/>
+            <a:ext cx="9509760" cy="310896"/>
           </a:xfrm>
           <a:prstGeom prst="rect">
             <a:avLst/>
@@ -33083,7 +33083,7 @@
           <a:p>
             <a:pPr algn="l"/>
             <a:r>
-              <a:rPr sz="1300" b="1" i="0">
+              <a:rPr sz="1250" b="1" i="0">
                 <a:solidFill>
                   <a:srgbClr val="F4801A"/>
                 </a:solidFill>
@@ -33102,8 +33102,8 @@
         </p:nvSpPr>
         <p:spPr>
           <a:xfrm>
-            <a:off x="548640" y="777240"/>
-            <a:ext cx="9966960" cy="822960"/>
+            <a:off x="548640" y="932688"/>
+            <a:ext cx="9966960" cy="777240"/>
           </a:xfrm>
           <a:prstGeom prst="rect">
             <a:avLst/>
@@ -33118,7 +33118,7 @@
           <a:p>
             <a:pPr algn="l"/>
             <a:r>
-              <a:rPr sz="3000" b="1" i="0">
+              <a:rPr sz="2700" b="1" i="0">
                 <a:solidFill>
                   <a:srgbClr val="1D2433"/>
                 </a:solidFill>
@@ -34105,8 +34105,8 @@
         </p:nvSpPr>
         <p:spPr>
           <a:xfrm>
-            <a:off x="548640" y="502920"/>
-            <a:ext cx="256032" cy="256032"/>
+            <a:off x="548640" y="475488"/>
+            <a:ext cx="237744" cy="237744"/>
           </a:xfrm>
           <a:prstGeom prst="rect">
             <a:avLst/>
@@ -34149,8 +34149,8 @@
         </p:nvSpPr>
         <p:spPr>
           <a:xfrm>
-            <a:off x="914400" y="457200"/>
-            <a:ext cx="9509760" cy="320040"/>
+            <a:off x="914400" y="402336"/>
+            <a:ext cx="9509760" cy="310896"/>
           </a:xfrm>
           <a:prstGeom prst="rect">
             <a:avLst/>
@@ -34165,7 +34165,7 @@
           <a:p>
             <a:pPr algn="l"/>
             <a:r>
-              <a:rPr sz="1300" b="1" i="0">
+              <a:rPr sz="1250" b="1" i="0">
                 <a:solidFill>
                   <a:srgbClr val="F4801A"/>
                 </a:solidFill>
@@ -34184,8 +34184,8 @@
         </p:nvSpPr>
         <p:spPr>
           <a:xfrm>
-            <a:off x="548640" y="777240"/>
-            <a:ext cx="9966960" cy="822960"/>
+            <a:off x="548640" y="932688"/>
+            <a:ext cx="9966960" cy="777240"/>
           </a:xfrm>
           <a:prstGeom prst="rect">
             <a:avLst/>
@@ -34200,7 +34200,7 @@
           <a:p>
             <a:pPr algn="l"/>
             <a:r>
-              <a:rPr sz="3000" b="1" i="0">
+              <a:rPr sz="2700" b="1" i="0">
                 <a:solidFill>
                   <a:srgbClr val="1D2433"/>
                 </a:solidFill>
@@ -35191,8 +35191,8 @@
         </p:nvSpPr>
         <p:spPr>
           <a:xfrm>
-            <a:off x="548640" y="502920"/>
-            <a:ext cx="256032" cy="256032"/>
+            <a:off x="548640" y="475488"/>
+            <a:ext cx="237744" cy="237744"/>
           </a:xfrm>
           <a:prstGeom prst="rect">
             <a:avLst/>
@@ -35235,8 +35235,8 @@
         </p:nvSpPr>
         <p:spPr>
           <a:xfrm>
-            <a:off x="914400" y="457200"/>
-            <a:ext cx="9509760" cy="320040"/>
+            <a:off x="914400" y="402336"/>
+            <a:ext cx="9509760" cy="310896"/>
           </a:xfrm>
           <a:prstGeom prst="rect">
             <a:avLst/>
@@ -35251,7 +35251,7 @@
           <a:p>
             <a:pPr algn="l"/>
             <a:r>
-              <a:rPr sz="1300" b="1" i="0">
+              <a:rPr sz="1250" b="1" i="0">
                 <a:solidFill>
                   <a:srgbClr val="F4801A"/>
                 </a:solidFill>
@@ -35270,8 +35270,8 @@
         </p:nvSpPr>
         <p:spPr>
           <a:xfrm>
-            <a:off x="548640" y="777240"/>
-            <a:ext cx="9966960" cy="822960"/>
+            <a:off x="548640" y="932688"/>
+            <a:ext cx="9966960" cy="777240"/>
           </a:xfrm>
           <a:prstGeom prst="rect">
             <a:avLst/>
@@ -35286,7 +35286,7 @@
           <a:p>
             <a:pPr algn="l"/>
             <a:r>
-              <a:rPr sz="3000" b="1" i="0">
+              <a:rPr sz="2700" b="1" i="0">
                 <a:solidFill>
                   <a:srgbClr val="1D2433"/>
                 </a:solidFill>
@@ -36273,8 +36273,8 @@
         </p:nvSpPr>
         <p:spPr>
           <a:xfrm>
-            <a:off x="548640" y="502920"/>
-            <a:ext cx="256032" cy="256032"/>
+            <a:off x="548640" y="475488"/>
+            <a:ext cx="237744" cy="237744"/>
           </a:xfrm>
           <a:prstGeom prst="rect">
             <a:avLst/>
@@ -36317,8 +36317,8 @@
         </p:nvSpPr>
         <p:spPr>
           <a:xfrm>
-            <a:off x="914400" y="457200"/>
-            <a:ext cx="9509760" cy="320040"/>
+            <a:off x="914400" y="402336"/>
+            <a:ext cx="9509760" cy="310896"/>
           </a:xfrm>
           <a:prstGeom prst="rect">
             <a:avLst/>
@@ -36333,7 +36333,7 @@
           <a:p>
             <a:pPr algn="l"/>
             <a:r>
-              <a:rPr sz="1300" b="1" i="0">
+              <a:rPr sz="1250" b="1" i="0">
                 <a:solidFill>
                   <a:srgbClr val="F4801A"/>
                 </a:solidFill>
@@ -36352,8 +36352,8 @@
         </p:nvSpPr>
         <p:spPr>
           <a:xfrm>
-            <a:off x="548640" y="777240"/>
-            <a:ext cx="9966960" cy="822960"/>
+            <a:off x="548640" y="932688"/>
+            <a:ext cx="9966960" cy="777240"/>
           </a:xfrm>
           <a:prstGeom prst="rect">
             <a:avLst/>
@@ -36368,7 +36368,7 @@
           <a:p>
             <a:pPr algn="l"/>
             <a:r>
-              <a:rPr sz="3000" b="1" i="0">
+              <a:rPr sz="2700" b="1" i="0">
                 <a:solidFill>
                   <a:srgbClr val="1D2433"/>
                 </a:solidFill>
@@ -37184,8 +37184,8 @@
         </p:nvSpPr>
         <p:spPr>
           <a:xfrm>
-            <a:off x="548640" y="502920"/>
-            <a:ext cx="256032" cy="256032"/>
+            <a:off x="548640" y="475488"/>
+            <a:ext cx="237744" cy="237744"/>
           </a:xfrm>
           <a:prstGeom prst="rect">
             <a:avLst/>
@@ -37228,8 +37228,8 @@
         </p:nvSpPr>
         <p:spPr>
           <a:xfrm>
-            <a:off x="914400" y="457200"/>
-            <a:ext cx="9509760" cy="320040"/>
+            <a:off x="914400" y="402336"/>
+            <a:ext cx="9509760" cy="310896"/>
           </a:xfrm>
           <a:prstGeom prst="rect">
             <a:avLst/>
@@ -37244,7 +37244,7 @@
           <a:p>
             <a:pPr algn="l"/>
             <a:r>
-              <a:rPr sz="1300" b="1" i="0">
+              <a:rPr sz="1250" b="1" i="0">
                 <a:solidFill>
                   <a:srgbClr val="F4801A"/>
                 </a:solidFill>
@@ -37263,8 +37263,8 @@
         </p:nvSpPr>
         <p:spPr>
           <a:xfrm>
-            <a:off x="548640" y="777240"/>
-            <a:ext cx="9966960" cy="822960"/>
+            <a:off x="548640" y="932688"/>
+            <a:ext cx="9966960" cy="777240"/>
           </a:xfrm>
           <a:prstGeom prst="rect">
             <a:avLst/>
@@ -37279,7 +37279,7 @@
           <a:p>
             <a:pPr algn="l"/>
             <a:r>
-              <a:rPr sz="3000" b="1" i="0">
+              <a:rPr sz="2700" b="1" i="0">
                 <a:solidFill>
                   <a:srgbClr val="1D2433"/>
                 </a:solidFill>
@@ -38266,8 +38266,8 @@
         </p:nvSpPr>
         <p:spPr>
           <a:xfrm>
-            <a:off x="548640" y="502920"/>
-            <a:ext cx="256032" cy="256032"/>
+            <a:off x="548640" y="475488"/>
+            <a:ext cx="237744" cy="237744"/>
           </a:xfrm>
           <a:prstGeom prst="rect">
             <a:avLst/>
@@ -38310,8 +38310,8 @@
         </p:nvSpPr>
         <p:spPr>
           <a:xfrm>
-            <a:off x="914400" y="457200"/>
-            <a:ext cx="9509760" cy="320040"/>
+            <a:off x="914400" y="402336"/>
+            <a:ext cx="9509760" cy="310896"/>
           </a:xfrm>
           <a:prstGeom prst="rect">
             <a:avLst/>
@@ -38326,7 +38326,7 @@
           <a:p>
             <a:pPr algn="l"/>
             <a:r>
-              <a:rPr sz="1300" b="1" i="0">
+              <a:rPr sz="1250" b="1" i="0">
                 <a:solidFill>
                   <a:srgbClr val="F4801A"/>
                 </a:solidFill>
@@ -38345,8 +38345,8 @@
         </p:nvSpPr>
         <p:spPr>
           <a:xfrm>
-            <a:off x="548640" y="777240"/>
-            <a:ext cx="9966960" cy="822960"/>
+            <a:off x="548640" y="932688"/>
+            <a:ext cx="9966960" cy="777240"/>
           </a:xfrm>
           <a:prstGeom prst="rect">
             <a:avLst/>
@@ -38361,7 +38361,7 @@
           <a:p>
             <a:pPr algn="l"/>
             <a:r>
-              <a:rPr sz="3000" b="1" i="0">
+              <a:rPr sz="2700" b="1" i="0">
                 <a:solidFill>
                   <a:srgbClr val="1D2433"/>
                 </a:solidFill>
@@ -39177,8 +39177,8 @@
         </p:nvSpPr>
         <p:spPr>
           <a:xfrm>
-            <a:off x="548640" y="502920"/>
-            <a:ext cx="256032" cy="256032"/>
+            <a:off x="548640" y="475488"/>
+            <a:ext cx="237744" cy="237744"/>
           </a:xfrm>
           <a:prstGeom prst="rect">
             <a:avLst/>
@@ -39221,8 +39221,8 @@
         </p:nvSpPr>
         <p:spPr>
           <a:xfrm>
-            <a:off x="914400" y="457200"/>
-            <a:ext cx="9509760" cy="320040"/>
+            <a:off x="914400" y="402336"/>
+            <a:ext cx="9509760" cy="310896"/>
           </a:xfrm>
           <a:prstGeom prst="rect">
             <a:avLst/>
@@ -39237,7 +39237,7 @@
           <a:p>
             <a:pPr algn="l"/>
             <a:r>
-              <a:rPr sz="1300" b="1" i="0">
+              <a:rPr sz="1250" b="1" i="0">
                 <a:solidFill>
                   <a:srgbClr val="F4801A"/>
                 </a:solidFill>
@@ -39256,8 +39256,8 @@
         </p:nvSpPr>
         <p:spPr>
           <a:xfrm>
-            <a:off x="548640" y="777240"/>
-            <a:ext cx="9966960" cy="822960"/>
+            <a:off x="548640" y="932688"/>
+            <a:ext cx="9966960" cy="777240"/>
           </a:xfrm>
           <a:prstGeom prst="rect">
             <a:avLst/>
@@ -39272,7 +39272,7 @@
           <a:p>
             <a:pPr algn="l"/>
             <a:r>
-              <a:rPr sz="3000" b="1" i="0">
+              <a:rPr sz="2700" b="1" i="0">
                 <a:solidFill>
                   <a:srgbClr val="1D2433"/>
                 </a:solidFill>
@@ -40644,8 +40644,8 @@
         </p:nvSpPr>
         <p:spPr>
           <a:xfrm>
-            <a:off x="548640" y="502920"/>
-            <a:ext cx="256032" cy="256032"/>
+            <a:off x="548640" y="475488"/>
+            <a:ext cx="237744" cy="237744"/>
           </a:xfrm>
           <a:prstGeom prst="rect">
             <a:avLst/>
@@ -40688,8 +40688,8 @@
         </p:nvSpPr>
         <p:spPr>
           <a:xfrm>
-            <a:off x="914400" y="457200"/>
-            <a:ext cx="9509760" cy="320040"/>
+            <a:off x="914400" y="402336"/>
+            <a:ext cx="9509760" cy="310896"/>
           </a:xfrm>
           <a:prstGeom prst="rect">
             <a:avLst/>
@@ -40704,7 +40704,7 @@
           <a:p>
             <a:pPr algn="l"/>
             <a:r>
-              <a:rPr sz="1300" b="1" i="0">
+              <a:rPr sz="1250" b="1" i="0">
                 <a:solidFill>
                   <a:srgbClr val="F4801A"/>
                 </a:solidFill>
@@ -40723,8 +40723,8 @@
         </p:nvSpPr>
         <p:spPr>
           <a:xfrm>
-            <a:off x="548640" y="777240"/>
-            <a:ext cx="9966960" cy="822960"/>
+            <a:off x="548640" y="932688"/>
+            <a:ext cx="9966960" cy="777240"/>
           </a:xfrm>
           <a:prstGeom prst="rect">
             <a:avLst/>
@@ -40739,7 +40739,7 @@
           <a:p>
             <a:pPr algn="l"/>
             <a:r>
-              <a:rPr sz="3000" b="1" i="0">
+              <a:rPr sz="2700" b="1" i="0">
                 <a:solidFill>
                   <a:srgbClr val="1D2433"/>
                 </a:solidFill>
@@ -41035,8 +41035,8 @@
         </p:nvSpPr>
         <p:spPr>
           <a:xfrm>
-            <a:off x="548640" y="502920"/>
-            <a:ext cx="256032" cy="256032"/>
+            <a:off x="548640" y="475488"/>
+            <a:ext cx="237744" cy="237744"/>
           </a:xfrm>
           <a:prstGeom prst="rect">
             <a:avLst/>
@@ -41079,8 +41079,8 @@
         </p:nvSpPr>
         <p:spPr>
           <a:xfrm>
-            <a:off x="914400" y="457200"/>
-            <a:ext cx="9509760" cy="320040"/>
+            <a:off x="914400" y="402336"/>
+            <a:ext cx="9509760" cy="310896"/>
           </a:xfrm>
           <a:prstGeom prst="rect">
             <a:avLst/>
@@ -41095,7 +41095,7 @@
           <a:p>
             <a:pPr algn="l"/>
             <a:r>
-              <a:rPr sz="1300" b="1" i="0">
+              <a:rPr sz="1250" b="1" i="0">
                 <a:solidFill>
                   <a:srgbClr val="2A9D8F"/>
                 </a:solidFill>
@@ -41114,8 +41114,8 @@
         </p:nvSpPr>
         <p:spPr>
           <a:xfrm>
-            <a:off x="548640" y="777240"/>
-            <a:ext cx="9966960" cy="822960"/>
+            <a:off x="548640" y="932688"/>
+            <a:ext cx="9966960" cy="777240"/>
           </a:xfrm>
           <a:prstGeom prst="rect">
             <a:avLst/>
@@ -41130,7 +41130,7 @@
           <a:p>
             <a:pPr algn="l"/>
             <a:r>
-              <a:rPr sz="3000" b="1" i="0">
+              <a:rPr sz="2700" b="1" i="0">
                 <a:solidFill>
                   <a:srgbClr val="1D2433"/>
                 </a:solidFill>
@@ -41472,8 +41472,8 @@
         </p:nvSpPr>
         <p:spPr>
           <a:xfrm>
-            <a:off x="548640" y="502920"/>
-            <a:ext cx="256032" cy="256032"/>
+            <a:off x="548640" y="475488"/>
+            <a:ext cx="237744" cy="237744"/>
           </a:xfrm>
           <a:prstGeom prst="rect">
             <a:avLst/>
@@ -41516,8 +41516,8 @@
         </p:nvSpPr>
         <p:spPr>
           <a:xfrm>
-            <a:off x="914400" y="457200"/>
-            <a:ext cx="9509760" cy="320040"/>
+            <a:off x="914400" y="402336"/>
+            <a:ext cx="9509760" cy="310896"/>
           </a:xfrm>
           <a:prstGeom prst="rect">
             <a:avLst/>
@@ -41532,7 +41532,7 @@
           <a:p>
             <a:pPr algn="l"/>
             <a:r>
-              <a:rPr sz="1300" b="1" i="0">
+              <a:rPr sz="1250" b="1" i="0">
                 <a:solidFill>
                   <a:srgbClr val="F4801A"/>
                 </a:solidFill>
@@ -41551,8 +41551,8 @@
         </p:nvSpPr>
         <p:spPr>
           <a:xfrm>
-            <a:off x="548640" y="777240"/>
-            <a:ext cx="9966960" cy="822960"/>
+            <a:off x="548640" y="932688"/>
+            <a:ext cx="9966960" cy="777240"/>
           </a:xfrm>
           <a:prstGeom prst="rect">
             <a:avLst/>
@@ -41567,7 +41567,7 @@
           <a:p>
             <a:pPr algn="l"/>
             <a:r>
-              <a:rPr sz="3000" b="1" i="0">
+              <a:rPr sz="2700" b="1" i="0">
                 <a:solidFill>
                   <a:srgbClr val="1D2433"/>
                 </a:solidFill>
@@ -41863,8 +41863,8 @@
         </p:nvSpPr>
         <p:spPr>
           <a:xfrm>
-            <a:off x="548640" y="502920"/>
-            <a:ext cx="256032" cy="256032"/>
+            <a:off x="548640" y="475488"/>
+            <a:ext cx="237744" cy="237744"/>
           </a:xfrm>
           <a:prstGeom prst="rect">
             <a:avLst/>
@@ -41907,8 +41907,8 @@
         </p:nvSpPr>
         <p:spPr>
           <a:xfrm>
-            <a:off x="914400" y="457200"/>
-            <a:ext cx="9509760" cy="320040"/>
+            <a:off x="914400" y="402336"/>
+            <a:ext cx="9509760" cy="310896"/>
           </a:xfrm>
           <a:prstGeom prst="rect">
             <a:avLst/>
@@ -41923,7 +41923,7 @@
           <a:p>
             <a:pPr algn="l"/>
             <a:r>
-              <a:rPr sz="1300" b="1" i="0">
+              <a:rPr sz="1250" b="1" i="0">
                 <a:solidFill>
                   <a:srgbClr val="F4801A"/>
                 </a:solidFill>
@@ -41942,8 +41942,8 @@
         </p:nvSpPr>
         <p:spPr>
           <a:xfrm>
-            <a:off x="548640" y="777240"/>
-            <a:ext cx="9966960" cy="822960"/>
+            <a:off x="548640" y="932688"/>
+            <a:ext cx="9966960" cy="777240"/>
           </a:xfrm>
           <a:prstGeom prst="rect">
             <a:avLst/>
@@ -41958,7 +41958,7 @@
           <a:p>
             <a:pPr algn="l"/>
             <a:r>
-              <a:rPr sz="3000" b="1" i="0">
+              <a:rPr sz="2700" b="1" i="0">
                 <a:solidFill>
                   <a:srgbClr val="1D2433"/>
                 </a:solidFill>
@@ -42774,8 +42774,8 @@
         </p:nvSpPr>
         <p:spPr>
           <a:xfrm>
-            <a:off x="548640" y="502920"/>
-            <a:ext cx="256032" cy="256032"/>
+            <a:off x="548640" y="475488"/>
+            <a:ext cx="237744" cy="237744"/>
           </a:xfrm>
           <a:prstGeom prst="rect">
             <a:avLst/>
@@ -42818,8 +42818,8 @@
         </p:nvSpPr>
         <p:spPr>
           <a:xfrm>
-            <a:off x="914400" y="457200"/>
-            <a:ext cx="9509760" cy="320040"/>
+            <a:off x="914400" y="402336"/>
+            <a:ext cx="9509760" cy="310896"/>
           </a:xfrm>
           <a:prstGeom prst="rect">
             <a:avLst/>
@@ -42834,7 +42834,7 @@
           <a:p>
             <a:pPr algn="l"/>
             <a:r>
-              <a:rPr sz="1300" b="1" i="0">
+              <a:rPr sz="1250" b="1" i="0">
                 <a:solidFill>
                   <a:srgbClr val="2A9D8F"/>
                 </a:solidFill>
@@ -42853,8 +42853,8 @@
         </p:nvSpPr>
         <p:spPr>
           <a:xfrm>
-            <a:off x="548640" y="777240"/>
-            <a:ext cx="9966960" cy="822960"/>
+            <a:off x="548640" y="932688"/>
+            <a:ext cx="9966960" cy="777240"/>
           </a:xfrm>
           <a:prstGeom prst="rect">
             <a:avLst/>
@@ -42869,7 +42869,7 @@
           <a:p>
             <a:pPr algn="l"/>
             <a:r>
-              <a:rPr sz="3000" b="1" i="0">
+              <a:rPr sz="2700" b="1" i="0">
                 <a:solidFill>
                   <a:srgbClr val="1D2433"/>
                 </a:solidFill>
@@ -43211,8 +43211,8 @@
         </p:nvSpPr>
         <p:spPr>
           <a:xfrm>
-            <a:off x="548640" y="502920"/>
-            <a:ext cx="256032" cy="256032"/>
+            <a:off x="548640" y="475488"/>
+            <a:ext cx="237744" cy="237744"/>
           </a:xfrm>
           <a:prstGeom prst="rect">
             <a:avLst/>
@@ -43255,8 +43255,8 @@
         </p:nvSpPr>
         <p:spPr>
           <a:xfrm>
-            <a:off x="914400" y="457200"/>
-            <a:ext cx="9509760" cy="320040"/>
+            <a:off x="914400" y="402336"/>
+            <a:ext cx="9509760" cy="310896"/>
           </a:xfrm>
           <a:prstGeom prst="rect">
             <a:avLst/>
@@ -43271,7 +43271,7 @@
           <a:p>
             <a:pPr algn="l"/>
             <a:r>
-              <a:rPr sz="1300" b="1" i="0">
+              <a:rPr sz="1250" b="1" i="0">
                 <a:solidFill>
                   <a:srgbClr val="F4801A"/>
                 </a:solidFill>
@@ -43290,8 +43290,8 @@
         </p:nvSpPr>
         <p:spPr>
           <a:xfrm>
-            <a:off x="548640" y="777240"/>
-            <a:ext cx="9966960" cy="822960"/>
+            <a:off x="548640" y="932688"/>
+            <a:ext cx="9966960" cy="777240"/>
           </a:xfrm>
           <a:prstGeom prst="rect">
             <a:avLst/>
@@ -43306,7 +43306,7 @@
           <a:p>
             <a:pPr algn="l"/>
             <a:r>
-              <a:rPr sz="3000" b="1" i="0">
+              <a:rPr sz="2700" b="1" i="0">
                 <a:solidFill>
                   <a:srgbClr val="1D2433"/>
                 </a:solidFill>
@@ -43602,8 +43602,8 @@
         </p:nvSpPr>
         <p:spPr>
           <a:xfrm>
-            <a:off x="548640" y="502920"/>
-            <a:ext cx="256032" cy="256032"/>
+            <a:off x="548640" y="475488"/>
+            <a:ext cx="237744" cy="237744"/>
           </a:xfrm>
           <a:prstGeom prst="rect">
             <a:avLst/>
@@ -43646,8 +43646,8 @@
         </p:nvSpPr>
         <p:spPr>
           <a:xfrm>
-            <a:off x="914400" y="457200"/>
-            <a:ext cx="9509760" cy="320040"/>
+            <a:off x="914400" y="402336"/>
+            <a:ext cx="9509760" cy="310896"/>
           </a:xfrm>
           <a:prstGeom prst="rect">
             <a:avLst/>
@@ -43662,7 +43662,7 @@
           <a:p>
             <a:pPr algn="l"/>
             <a:r>
-              <a:rPr sz="1300" b="1" i="0">
+              <a:rPr sz="1250" b="1" i="0">
                 <a:solidFill>
                   <a:srgbClr val="2A9D8F"/>
                 </a:solidFill>
@@ -43681,8 +43681,8 @@
         </p:nvSpPr>
         <p:spPr>
           <a:xfrm>
-            <a:off x="548640" y="777240"/>
-            <a:ext cx="9966960" cy="822960"/>
+            <a:off x="548640" y="932688"/>
+            <a:ext cx="9966960" cy="777240"/>
           </a:xfrm>
           <a:prstGeom prst="rect">
             <a:avLst/>
@@ -43697,7 +43697,7 @@
           <a:p>
             <a:pPr algn="l"/>
             <a:r>
-              <a:rPr sz="3000" b="1" i="0">
+              <a:rPr sz="2700" b="1" i="0">
                 <a:solidFill>
                   <a:srgbClr val="1D2433"/>
                 </a:solidFill>
@@ -44067,8 +44067,8 @@
         </p:nvSpPr>
         <p:spPr>
           <a:xfrm>
-            <a:off x="548640" y="502920"/>
-            <a:ext cx="256032" cy="256032"/>
+            <a:off x="548640" y="475488"/>
+            <a:ext cx="237744" cy="237744"/>
           </a:xfrm>
           <a:prstGeom prst="rect">
             <a:avLst/>
@@ -44111,8 +44111,8 @@
         </p:nvSpPr>
         <p:spPr>
           <a:xfrm>
-            <a:off x="914400" y="457200"/>
-            <a:ext cx="9509760" cy="320040"/>
+            <a:off x="914400" y="402336"/>
+            <a:ext cx="9509760" cy="310896"/>
           </a:xfrm>
           <a:prstGeom prst="rect">
             <a:avLst/>
@@ -44127,7 +44127,7 @@
           <a:p>
             <a:pPr algn="l"/>
             <a:r>
-              <a:rPr sz="1300" b="1" i="0">
+              <a:rPr sz="1250" b="1" i="0">
                 <a:solidFill>
                   <a:srgbClr val="F4801A"/>
                 </a:solidFill>
@@ -44146,8 +44146,8 @@
         </p:nvSpPr>
         <p:spPr>
           <a:xfrm>
-            <a:off x="548640" y="777240"/>
-            <a:ext cx="9966960" cy="822960"/>
+            <a:off x="548640" y="932688"/>
+            <a:ext cx="9966960" cy="777240"/>
           </a:xfrm>
           <a:prstGeom prst="rect">
             <a:avLst/>
@@ -44162,7 +44162,7 @@
           <a:p>
             <a:pPr algn="l"/>
             <a:r>
-              <a:rPr sz="3000" b="1" i="0">
+              <a:rPr sz="2700" b="1" i="0">
                 <a:solidFill>
                   <a:srgbClr val="1D2433"/>
                 </a:solidFill>
@@ -44458,8 +44458,8 @@
         </p:nvSpPr>
         <p:spPr>
           <a:xfrm>
-            <a:off x="548640" y="502920"/>
-            <a:ext cx="256032" cy="256032"/>
+            <a:off x="548640" y="475488"/>
+            <a:ext cx="237744" cy="237744"/>
           </a:xfrm>
           <a:prstGeom prst="rect">
             <a:avLst/>
@@ -44502,8 +44502,8 @@
         </p:nvSpPr>
         <p:spPr>
           <a:xfrm>
-            <a:off x="914400" y="457200"/>
-            <a:ext cx="9509760" cy="320040"/>
+            <a:off x="914400" y="402336"/>
+            <a:ext cx="9509760" cy="310896"/>
           </a:xfrm>
           <a:prstGeom prst="rect">
             <a:avLst/>
@@ -44518,7 +44518,7 @@
           <a:p>
             <a:pPr algn="l"/>
             <a:r>
-              <a:rPr sz="1300" b="1" i="0">
+              <a:rPr sz="1250" b="1" i="0">
                 <a:solidFill>
                   <a:srgbClr val="2A9D8F"/>
                 </a:solidFill>
@@ -44537,8 +44537,8 @@
         </p:nvSpPr>
         <p:spPr>
           <a:xfrm>
-            <a:off x="548640" y="777240"/>
-            <a:ext cx="9966960" cy="822960"/>
+            <a:off x="548640" y="932688"/>
+            <a:ext cx="9966960" cy="777240"/>
           </a:xfrm>
           <a:prstGeom prst="rect">
             <a:avLst/>
@@ -44553,7 +44553,7 @@
           <a:p>
             <a:pPr algn="l"/>
             <a:r>
-              <a:rPr sz="3000" b="1" i="0">
+              <a:rPr sz="2700" b="1" i="0">
                 <a:solidFill>
                   <a:srgbClr val="1D2433"/>
                 </a:solidFill>
@@ -44895,8 +44895,8 @@
         </p:nvSpPr>
         <p:spPr>
           <a:xfrm>
-            <a:off x="548640" y="502920"/>
-            <a:ext cx="256032" cy="256032"/>
+            <a:off x="548640" y="475488"/>
+            <a:ext cx="237744" cy="237744"/>
           </a:xfrm>
           <a:prstGeom prst="rect">
             <a:avLst/>
@@ -44939,8 +44939,8 @@
         </p:nvSpPr>
         <p:spPr>
           <a:xfrm>
-            <a:off x="914400" y="457200"/>
-            <a:ext cx="9509760" cy="320040"/>
+            <a:off x="914400" y="402336"/>
+            <a:ext cx="9509760" cy="310896"/>
           </a:xfrm>
           <a:prstGeom prst="rect">
             <a:avLst/>
@@ -44955,7 +44955,7 @@
           <a:p>
             <a:pPr algn="l"/>
             <a:r>
-              <a:rPr sz="1300" b="1" i="0">
+              <a:rPr sz="1250" b="1" i="0">
                 <a:solidFill>
                   <a:srgbClr val="F4801A"/>
                 </a:solidFill>
@@ -44974,8 +44974,8 @@
         </p:nvSpPr>
         <p:spPr>
           <a:xfrm>
-            <a:off x="548640" y="777240"/>
-            <a:ext cx="9966960" cy="822960"/>
+            <a:off x="548640" y="932688"/>
+            <a:ext cx="9966960" cy="777240"/>
           </a:xfrm>
           <a:prstGeom prst="rect">
             <a:avLst/>
@@ -44990,7 +44990,7 @@
           <a:p>
             <a:pPr algn="l"/>
             <a:r>
-              <a:rPr sz="3000" b="1" i="0">
+              <a:rPr sz="2700" b="1" i="0">
                 <a:solidFill>
                   <a:srgbClr val="1D2433"/>
                 </a:solidFill>
@@ -45286,8 +45286,8 @@
         </p:nvSpPr>
         <p:spPr>
           <a:xfrm>
-            <a:off x="548640" y="502920"/>
-            <a:ext cx="256032" cy="256032"/>
+            <a:off x="548640" y="475488"/>
+            <a:ext cx="237744" cy="237744"/>
           </a:xfrm>
           <a:prstGeom prst="rect">
             <a:avLst/>
@@ -45330,8 +45330,8 @@
         </p:nvSpPr>
         <p:spPr>
           <a:xfrm>
-            <a:off x="914400" y="457200"/>
-            <a:ext cx="9509760" cy="320040"/>
+            <a:off x="914400" y="402336"/>
+            <a:ext cx="9509760" cy="310896"/>
           </a:xfrm>
           <a:prstGeom prst="rect">
             <a:avLst/>
@@ -45346,7 +45346,7 @@
           <a:p>
             <a:pPr algn="l"/>
             <a:r>
-              <a:rPr sz="1300" b="1" i="0">
+              <a:rPr sz="1250" b="1" i="0">
                 <a:solidFill>
                   <a:srgbClr val="2A9D8F"/>
                 </a:solidFill>
@@ -45365,8 +45365,8 @@
         </p:nvSpPr>
         <p:spPr>
           <a:xfrm>
-            <a:off x="548640" y="777240"/>
-            <a:ext cx="9966960" cy="822960"/>
+            <a:off x="548640" y="932688"/>
+            <a:ext cx="9966960" cy="777240"/>
           </a:xfrm>
           <a:prstGeom prst="rect">
             <a:avLst/>
@@ -45381,7 +45381,7 @@
           <a:p>
             <a:pPr algn="l"/>
             <a:r>
-              <a:rPr sz="3000" b="1" i="0">
+              <a:rPr sz="2700" b="1" i="0">
                 <a:solidFill>
                   <a:srgbClr val="1D2433"/>
                 </a:solidFill>
@@ -45907,8 +45907,8 @@
         </p:nvSpPr>
         <p:spPr>
           <a:xfrm>
-            <a:off x="548640" y="502920"/>
-            <a:ext cx="256032" cy="256032"/>
+            <a:off x="548640" y="475488"/>
+            <a:ext cx="237744" cy="237744"/>
           </a:xfrm>
           <a:prstGeom prst="rect">
             <a:avLst/>
@@ -45951,8 +45951,8 @@
         </p:nvSpPr>
         <p:spPr>
           <a:xfrm>
-            <a:off x="914400" y="457200"/>
-            <a:ext cx="9509760" cy="320040"/>
+            <a:off x="914400" y="402336"/>
+            <a:ext cx="9509760" cy="310896"/>
           </a:xfrm>
           <a:prstGeom prst="rect">
             <a:avLst/>
@@ -45967,7 +45967,7 @@
           <a:p>
             <a:pPr algn="l"/>
             <a:r>
-              <a:rPr sz="1300" b="1" i="0">
+              <a:rPr sz="1250" b="1" i="0">
                 <a:solidFill>
                   <a:srgbClr val="F4801A"/>
                 </a:solidFill>
@@ -45986,8 +45986,8 @@
         </p:nvSpPr>
         <p:spPr>
           <a:xfrm>
-            <a:off x="548640" y="777240"/>
-            <a:ext cx="9966960" cy="822960"/>
+            <a:off x="548640" y="932688"/>
+            <a:ext cx="9966960" cy="777240"/>
           </a:xfrm>
           <a:prstGeom prst="rect">
             <a:avLst/>
@@ -46002,7 +46002,7 @@
           <a:p>
             <a:pPr algn="l"/>
             <a:r>
-              <a:rPr sz="3000" b="1" i="0">
+              <a:rPr sz="2700" b="1" i="0">
                 <a:solidFill>
                   <a:srgbClr val="1D2433"/>
                 </a:solidFill>
@@ -46989,8 +46989,8 @@
         </p:nvSpPr>
         <p:spPr>
           <a:xfrm>
-            <a:off x="548640" y="502920"/>
-            <a:ext cx="256032" cy="256032"/>
+            <a:off x="548640" y="475488"/>
+            <a:ext cx="237744" cy="237744"/>
           </a:xfrm>
           <a:prstGeom prst="rect">
             <a:avLst/>
@@ -47033,8 +47033,8 @@
         </p:nvSpPr>
         <p:spPr>
           <a:xfrm>
-            <a:off x="914400" y="457200"/>
-            <a:ext cx="9509760" cy="320040"/>
+            <a:off x="914400" y="402336"/>
+            <a:ext cx="9509760" cy="310896"/>
           </a:xfrm>
           <a:prstGeom prst="rect">
             <a:avLst/>
@@ -47049,7 +47049,7 @@
           <a:p>
             <a:pPr algn="l"/>
             <a:r>
-              <a:rPr sz="1300" b="1" i="0">
+              <a:rPr sz="1250" b="1" i="0">
                 <a:solidFill>
                   <a:srgbClr val="F4801A"/>
                 </a:solidFill>
@@ -47068,8 +47068,8 @@
         </p:nvSpPr>
         <p:spPr>
           <a:xfrm>
-            <a:off x="548640" y="777240"/>
-            <a:ext cx="9966960" cy="822960"/>
+            <a:off x="548640" y="932688"/>
+            <a:ext cx="9966960" cy="777240"/>
           </a:xfrm>
           <a:prstGeom prst="rect">
             <a:avLst/>
@@ -47084,7 +47084,7 @@
           <a:p>
             <a:pPr algn="l"/>
             <a:r>
-              <a:rPr sz="3000" b="1" i="0">
+              <a:rPr sz="2700" b="1" i="0">
                 <a:solidFill>
                   <a:srgbClr val="1D2433"/>
                 </a:solidFill>
@@ -47900,8 +47900,8 @@
         </p:nvSpPr>
         <p:spPr>
           <a:xfrm>
-            <a:off x="548640" y="502920"/>
-            <a:ext cx="256032" cy="256032"/>
+            <a:off x="548640" y="475488"/>
+            <a:ext cx="237744" cy="237744"/>
           </a:xfrm>
           <a:prstGeom prst="rect">
             <a:avLst/>
@@ -47944,8 +47944,8 @@
         </p:nvSpPr>
         <p:spPr>
           <a:xfrm>
-            <a:off x="914400" y="457200"/>
-            <a:ext cx="9509760" cy="320040"/>
+            <a:off x="914400" y="402336"/>
+            <a:ext cx="9509760" cy="310896"/>
           </a:xfrm>
           <a:prstGeom prst="rect">
             <a:avLst/>
@@ -47960,7 +47960,7 @@
           <a:p>
             <a:pPr algn="l"/>
             <a:r>
-              <a:rPr sz="1300" b="1" i="0">
+              <a:rPr sz="1250" b="1" i="0">
                 <a:solidFill>
                   <a:srgbClr val="F4801A"/>
                 </a:solidFill>
@@ -47979,8 +47979,8 @@
         </p:nvSpPr>
         <p:spPr>
           <a:xfrm>
-            <a:off x="548640" y="777240"/>
-            <a:ext cx="9966960" cy="822960"/>
+            <a:off x="548640" y="932688"/>
+            <a:ext cx="9966960" cy="777240"/>
           </a:xfrm>
           <a:prstGeom prst="rect">
             <a:avLst/>
@@ -47995,7 +47995,7 @@
           <a:p>
             <a:pPr algn="l"/>
             <a:r>
-              <a:rPr sz="3000" b="1" i="0">
+              <a:rPr sz="2700" b="1" i="0">
                 <a:solidFill>
                   <a:srgbClr val="1D2433"/>
                 </a:solidFill>
@@ -48982,8 +48982,8 @@
         </p:nvSpPr>
         <p:spPr>
           <a:xfrm>
-            <a:off x="548640" y="502920"/>
-            <a:ext cx="256032" cy="256032"/>
+            <a:off x="548640" y="475488"/>
+            <a:ext cx="237744" cy="237744"/>
           </a:xfrm>
           <a:prstGeom prst="rect">
             <a:avLst/>
@@ -49026,8 +49026,8 @@
         </p:nvSpPr>
         <p:spPr>
           <a:xfrm>
-            <a:off x="914400" y="457200"/>
-            <a:ext cx="9509760" cy="320040"/>
+            <a:off x="914400" y="402336"/>
+            <a:ext cx="9509760" cy="310896"/>
           </a:xfrm>
           <a:prstGeom prst="rect">
             <a:avLst/>
@@ -49042,7 +49042,7 @@
           <a:p>
             <a:pPr algn="l"/>
             <a:r>
-              <a:rPr sz="1300" b="1" i="0">
+              <a:rPr sz="1250" b="1" i="0">
                 <a:solidFill>
                   <a:srgbClr val="F4801A"/>
                 </a:solidFill>
@@ -49061,8 +49061,8 @@
         </p:nvSpPr>
         <p:spPr>
           <a:xfrm>
-            <a:off x="548640" y="777240"/>
-            <a:ext cx="9966960" cy="822960"/>
+            <a:off x="548640" y="932688"/>
+            <a:ext cx="9966960" cy="777240"/>
           </a:xfrm>
           <a:prstGeom prst="rect">
             <a:avLst/>
@@ -49077,7 +49077,7 @@
           <a:p>
             <a:pPr algn="l"/>
             <a:r>
-              <a:rPr sz="3000" b="1" i="0">
+              <a:rPr sz="2700" b="1" i="0">
                 <a:solidFill>
                   <a:srgbClr val="1D2433"/>
                 </a:solidFill>

</xml_diff>